<commit_message>
fix(pptx): preserve click animation steps
Parse main-sequence next conditions from their owning containers and compile each sequence child as a distinct click boundary. Add unit, fixture, and browser coverage for stage clicks before slide navigation.
</commit_message>
<xml_diff>
--- a/tests/fixtures/pptx/playback-controlled.pptx
+++ b/tests/fixtures/pptx/playback-controlled.pptx
@@ -3235,10 +3235,13 @@
               <p:cTn id="2" dur="indefinite" nodeType="mainSeq">
                 <p:childTnLst>
                   <p:par>
-                    <p:cTn id="3" nodeType="clickEffect">
+                    <p:cTn id="3" fill="hold">
+                      <p:stCondLst>
+                        <p:cond delay="0"/>
+                      </p:stCondLst>
                       <p:childTnLst>
                         <p:par>
-                          <p:cTn id="4" presetID="10" presetClass="entr" nodeType="withEffect" fill="hold">
+                          <p:cTn id="4" presetID="10" presetClass="entr" nodeType="afterEffect" fill="hold">
                             <p:stCondLst>
                               <p:cond delay="0"/>
                             </p:stCondLst>
@@ -3286,6 +3289,20 @@
                   </p:par>
                 </p:childTnLst>
               </p:cTn>
+              <p:prevCondLst>
+                <p:cond evt="onPrev" delay="0">
+                  <p:tgtEl>
+                    <p:sldTgt/>
+                  </p:tgtEl>
+                </p:cond>
+              </p:prevCondLst>
+              <p:nextCondLst>
+                <p:cond evt="onNext" delay="0">
+                  <p:tgtEl>
+                    <p:sldTgt/>
+                  </p:tgtEl>
+                </p:cond>
+              </p:nextCondLst>
             </p:seq>
           </p:childTnLst>
         </p:cTn>

</xml_diff>